<commit_message>
feat: compile and update 19-slide standard presentation for Student Hub
</commit_message>
<xml_diff>
--- a/Student_Registration_Presentation.pptx
+++ b/Student_Registration_Presentation.pptx
@@ -3427,7 +3427,7 @@
               </a:defRPr>
             </a:pPr>
             <a:r>
-              <a:t>Frontend Design System</a:t>
+              <a:t>Frontend UI: Design System &amp; Styling</a:t>
             </a:r>
           </a:p>
         </p:txBody>
@@ -3511,7 +3511,7 @@
               </a:defRPr>
             </a:pPr>
             <a:r>
-              <a:t>The design system uses CSS variables to ensure brand consistency across light and dark modes.</a:t>
+              <a:t>Student Hub features a premium, responsive frontend design system inspired by the Apple Human Interface Guidelines.</a:t>
             </a:r>
           </a:p>
           <a:p>
@@ -3527,7 +3527,7 @@
               </a:defRPr>
             </a:pPr>
             <a:r>
-              <a:t>🎨 Primary Branded Colorways: Navy Blue (`#00317e`) representing security and Gold (`#D4AF37`) representing academic achievement.</a:t>
+              <a:t>🎨 Color Palette: Navy Blue (`#00317e`) representing authority and Gold (`#D4AF37`) representing academic excellence.</a:t>
             </a:r>
           </a:p>
           <a:p>
@@ -3543,7 +3543,7 @@
               </a:defRPr>
             </a:pPr>
             <a:r>
-              <a:t>🌓 System-wide Dark Mode: Changes styles dynamically using `[data-theme='dark']` settings and saves user choice.</a:t>
+              <a:t>🌓 Seamless Dark Mode: Implements dynamic dark styles via `[data-theme='dark']` and saves preference in `localStorage`.</a:t>
             </a:r>
           </a:p>
           <a:p>
@@ -3559,7 +3559,7 @@
               </a:defRPr>
             </a:pPr>
             <a:r>
-              <a:t>🖥️ Layout Elements: Premium glassmorphism cards, blur navigation bars, and rounded pill containers.</a:t>
+              <a:t>📱 Modern CSS Layouts: Fluid typography clamping, flexbox layouts, glassmorphism cards, and responsive viewports.</a:t>
             </a:r>
           </a:p>
           <a:p>
@@ -3575,7 +3575,7 @@
               </a:defRPr>
             </a:pPr>
             <a:r>
-              <a:t>📱 Variable Fonts Scales: System fonts (Inter, Public Sans) scale dynamically for clean readability.</a:t>
+              <a:t>♿ Accessibility Touch Targets: Minimum `44px x 44px` targets throughout for easy mobile tap interactions.</a:t>
             </a:r>
           </a:p>
         </p:txBody>
@@ -3926,7 +3926,7 @@
               </a:defRPr>
             </a:pPr>
             <a:r>
-              <a:t>The Interface Wizard Screens</a:t>
+              <a:t>Frontend UI: Multi-Step Registration Wizard</a:t>
             </a:r>
           </a:p>
         </p:txBody>
@@ -4055,7 +4055,7 @@
               </a:defRPr>
             </a:pPr>
             <a:r>
-              <a:t>Step 1: Identity</a:t>
+              <a:t>Step 1: Personal Info</a:t>
             </a:r>
           </a:p>
           <a:p>
@@ -4068,7 +4068,7 @@
               </a:defRPr>
             </a:pPr>
             <a:r>
-              <a:t>Personal details inputs featuring regex email checks and phone formatting.</a:t>
+              <a:t>First/Last Name, Date of Birth, Gender, Email checks, and formatted Phone inputs.</a:t>
             </a:r>
           </a:p>
         </p:txBody>
@@ -4152,7 +4152,7 @@
               </a:defRPr>
             </a:pPr>
             <a:r>
-              <a:t>Step 2: Location</a:t>
+              <a:t>Step 2: Mailing Address</a:t>
             </a:r>
           </a:p>
           <a:p>
@@ -4165,7 +4165,7 @@
               </a:defRPr>
             </a:pPr>
             <a:r>
-              <a:t>Collects mailing coordinates and postal address details.</a:t>
+              <a:t>Street address, City, State, ZIP code, and Country drop-down configurations.</a:t>
             </a:r>
           </a:p>
         </p:txBody>
@@ -4249,7 +4249,7 @@
               </a:defRPr>
             </a:pPr>
             <a:r>
-              <a:t>Step 3: Program</a:t>
+              <a:t>Step 3: Academic Details</a:t>
             </a:r>
           </a:p>
           <a:p>
@@ -4262,7 +4262,7 @@
               </a:defRPr>
             </a:pPr>
             <a:r>
-              <a:t>Academic selection mapping candidates to specific program majors.</a:t>
+              <a:t>High school name, Graduation year, Major selection, and Enrollment status.</a:t>
             </a:r>
           </a:p>
         </p:txBody>
@@ -4346,7 +4346,7 @@
               </a:defRPr>
             </a:pPr>
             <a:r>
-              <a:t>Step 4: Account</a:t>
+              <a:t>Step 4: Create Account</a:t>
             </a:r>
           </a:p>
           <a:p>
@@ -4359,7 +4359,7 @@
               </a:defRPr>
             </a:pPr>
             <a:r>
-              <a:t>Password meter validation and dynamic registration code generation.</a:t>
+              <a:t>Password inputs with a real-time strength checker and terms acceptance checkboxes.</a:t>
             </a:r>
           </a:p>
         </p:txBody>
@@ -4390,7 +4390,7 @@
               <a:spcAft>
                 <a:spcPts val="400"/>
               </a:spcAft>
-              <a:defRPr b="1" sz="1400">
+              <a:defRPr b="1">
                 <a:solidFill>
                   <a:srgbClr val="00317E"/>
                 </a:solidFill>
@@ -4398,7 +4398,7 @@
               </a:defRPr>
             </a:pPr>
             <a:r>
-              <a:t>💡 **User Experience Features:**</a:t>
+              <a:t>💡 **User Experience Logic:**</a:t>
             </a:r>
           </a:p>
           <a:p>
@@ -4411,11 +4411,11 @@
               </a:defRPr>
             </a:pPr>
             <a:r>
-              <a:t>• Seamless Navigation: Next/Previous controls maintain filled states, reducing user input frustration.</a:t>
+              <a:t>• Multi-Step controller: Uses vanilla ES6 JS state controls to hide/show panels without page refreshes.</a:t>
             </a:r>
             <a:br/>
             <a:r>
-              <a:t>• Form Validation Feedback: Immediate visual alerts are triggered before form submission to ensure database clean writes.</a:t>
+              <a:t>• Smart Error Redirects: If registration validation fails, the script identifies error panels and auto-scrolls to the first error field.</a:t>
             </a:r>
           </a:p>
         </p:txBody>
@@ -4621,7 +4621,7 @@
               </a:defRPr>
             </a:pPr>
             <a:r>
-              <a:t>A core security innovation in Student Hub is the elimination of external content delivery networks (CDNs) for key UI icons.</a:t>
+              <a:t>To eliminate third-party CDN security leaks and support offline deployments, the system self-hosts all design vectors.</a:t>
             </a:r>
           </a:p>
           <a:p>
@@ -4637,7 +4637,7 @@
               </a:defRPr>
             </a:pPr>
             <a:r>
-              <a:t>🔒 Asset Isolation: Serves the Material Symbols font file (`.ttf`) directly from local `/static/fonts` folders.</a:t>
+              <a:t>🔒 Asset Isolation: Stores the `Material Symbols Outlined` variable font (`.ttf`) directly inside `/static/fonts` directories.</a:t>
             </a:r>
           </a:p>
           <a:p>
@@ -4653,7 +4653,7 @@
               </a:defRPr>
             </a:pPr>
             <a:r>
-              <a:t>🛡️ Content Security Policy compliance: Prevents security blocks on external CDN domains by referencing assets from `'self'`.</a:t>
+              <a:t>🛡️ CSP Optimization: Satisfies restrictive Content Security Policies, whitelisting `'self'` for font loads instead of public CDN urls.</a:t>
             </a:r>
           </a:p>
           <a:p>
@@ -4669,7 +4669,7 @@
               </a:defRPr>
             </a:pPr>
             <a:r>
-              <a:t>🔌 Network Independence: The application loads fast in offline local dev, removing the risk of CDN outages.</a:t>
+              <a:t>🔌 Network Autonomy: Guarantees pages render properly and load instantly even when offline.</a:t>
             </a:r>
           </a:p>
           <a:p>
@@ -4685,7 +4685,7 @@
               </a:defRPr>
             </a:pPr>
             <a:r>
-              <a:t>🧩 Dynamic Font Rendering: Retains variable axis settings (optical sizes, fill axis, weights) through pure local CSS rules.</a:t>
+              <a:t>🧩 Variable Font Axes: Maintains clean CSS access to variable axis values (fill axes, weight, optical sizing) locally.</a:t>
             </a:r>
           </a:p>
         </p:txBody>
@@ -4785,7 +4785,7 @@
               </a:defRPr>
             </a:pPr>
             <a:r>
-              <a:t>✔ Download Binary</a:t>
+              <a:t>✔ Font Binary</a:t>
             </a:r>
           </a:p>
           <a:p>
@@ -4798,7 +4798,7 @@
               </a:defRPr>
             </a:pPr>
             <a:r>
-              <a:t>Pulled Google's official variable font file to project disk folders.</a:t>
+              <a:t>Stored MaterialSymbolsOutlined.ttf locally in the static folder.</a:t>
             </a:r>
           </a:p>
           <a:p>
@@ -4827,7 +4827,7 @@
               </a:defRPr>
             </a:pPr>
             <a:r>
-              <a:t>Added @font-face rules mapping families to '/static/fonts/' urls.</a:t>
+              <a:t>Added @font-face rules mapping font url resources to '/static/fonts/'.</a:t>
             </a:r>
           </a:p>
           <a:p>
@@ -4843,7 +4843,7 @@
               </a:defRPr>
             </a:pPr>
             <a:r>
-              <a:t>✔ Strict CSP settings</a:t>
+              <a:t>✔ CSP Lockdown</a:t>
             </a:r>
           </a:p>
           <a:p>
@@ -4856,7 +4856,7 @@
               </a:defRPr>
             </a:pPr>
             <a:r>
-              <a:t>Wiped out external font-src domains, whitelisting 'self' only.</a:t>
+              <a:t>Removed Google Fonts external connections, whitelist only 'self' in CSP.</a:t>
             </a:r>
           </a:p>
         </p:txBody>
@@ -5062,7 +5062,7 @@
               </a:defRPr>
             </a:pPr>
             <a:r>
-              <a:t>Student Hub implements strict backend audit tracking to secure administrative actions and session states.</a:t>
+              <a:t>The application implements strict operational auditing and session controllers to secure user states.</a:t>
             </a:r>
           </a:p>
           <a:p>
@@ -5078,7 +5078,7 @@
               </a:defRPr>
             </a:pPr>
             <a:r>
-              <a:t>🛡️ Separated Session Managers: Employs different authentication flows for Students and Admins, preventing privilege escalation.</a:t>
+              <a:t>🛡️ Role Session Separation: Segregates Admin and Student authentication logic, preventing privilege escalation.</a:t>
             </a:r>
           </a:p>
           <a:p>
@@ -5094,7 +5094,7 @@
               </a:defRPr>
             </a:pPr>
             <a:r>
-              <a:t>📜 Operational Audit Logging: Writes JSON logs (`audit.py`) tracking actions, user context, client IP, and target candidate IDs.</a:t>
+              <a:t>📜 JSON Audit Logging (audit.py): Logs operation payloads, user contexts, Client IPs, and target student IDs.</a:t>
             </a:r>
           </a:p>
           <a:p>
@@ -5110,7 +5110,7 @@
               </a:defRPr>
             </a:pPr>
             <a:r>
-              <a:t>🧹 Input Sanitizer Middleware: Cleans inbound inputs before they reach the DB to block SQL injections and XSS attempts.</a:t>
+              <a:t>🧹 Input Sanitizer: Clears input strings of SQL strings and script tags before processing to block XSS.</a:t>
             </a:r>
           </a:p>
           <a:p>
@@ -5126,7 +5126,7 @@
               </a:defRPr>
             </a:pPr>
             <a:r>
-              <a:t>🔑 Endpoint Token Protections: Protects backend APIs with JWT verification decorators (`@token_required`).</a:t>
+              <a:t>🔑 Token Authentication API: API endpoints use a `@token_required` decorator for JWT authorization.</a:t>
             </a:r>
           </a:p>
         </p:txBody>
@@ -5200,7 +5200,7 @@
           <a:p>
             <a:pPr>
               <a:spcAft>
-                <a:spcPts val="1200"/>
+                <a:spcPts val="1000"/>
               </a:spcAft>
               <a:defRPr sz="1200" b="1">
                 <a:solidFill>
@@ -5210,7 +5210,7 @@
               </a:defRPr>
             </a:pPr>
             <a:r>
-              <a:t>AUDIT LOGGER LOG SAMPLE</a:t>
+              <a:t>JSON AUDIT LOG SAMPLE</a:t>
             </a:r>
           </a:p>
           <a:p>
@@ -5226,11 +5226,11 @@
               </a:defRPr>
             </a:pPr>
             <a:r>
-              <a:t>2026-05-24 10:45:01 [INFO]</a:t>
+              <a:t>{</a:t>
             </a:r>
             <a:br/>
             <a:r>
-              <a:t>AuditLog: {</a:t>
+              <a:t>  "timestamp": "2026-05-24T10:45:01Z",</a:t>
             </a:r>
             <a:br/>
             <a:r>
@@ -5517,7 +5517,7 @@
               </a:defRPr>
             </a:pPr>
             <a:r>
-              <a:t>✨ Hero Canvas Particle Effects</a:t>
+              <a:t>✨ Hero Particle Canvas</a:t>
             </a:r>
           </a:p>
           <a:p>
@@ -5530,7 +5530,7 @@
               </a:defRPr>
             </a:pPr>
             <a:r>
-              <a:t>The index landing page features a custom floating canvas particle background that animates smoothly.</a:t>
+              <a:t>A custom JavaScript-based floating canvas particle background animates dynamically in the hero viewport, creating a premium look.</a:t>
             </a:r>
           </a:p>
         </p:txBody>
@@ -5614,7 +5614,7 @@
               </a:defRPr>
             </a:pPr>
             <a:r>
-              <a:t>⭕ Circular Progress Indicator</a:t>
+              <a:t>⭕ SVG Completion Ring</a:t>
             </a:r>
           </a:p>
           <a:p>
@@ -5627,7 +5627,7 @@
               </a:defRPr>
             </a:pPr>
             <a:r>
-              <a:t>The student dashboard features a dynamic SVG completion ring that updates based on profile fields filled.</a:t>
+              <a:t>The student dashboard displays an interactive SVG completion ring, calculating the percentage of completed profile fields.</a:t>
             </a:r>
           </a:p>
         </p:txBody>
@@ -5711,7 +5711,7 @@
               </a:defRPr>
             </a:pPr>
             <a:r>
-              <a:t>🎉 Confetti Overlay Celebration</a:t>
+              <a:t>🎉 Confetti Celebration</a:t>
             </a:r>
           </a:p>
           <a:p>
@@ -5724,7 +5724,7 @@
               </a:defRPr>
             </a:pPr>
             <a:r>
-              <a:t>When registration finishes, the confirmation screen triggers a confetti celebration to welcome the user.</a:t>
+              <a:t>Triggers a full-screen canvas confetti animation upon successful form submission to welcome new students.</a:t>
             </a:r>
           </a:p>
         </p:txBody>
@@ -5808,7 +5808,7 @@
               </a:defRPr>
             </a:pPr>
             <a:r>
-              <a:t>🌓 Dark &amp; Light Modes Visuals</a:t>
+              <a:t>🌓 Dark &amp; Light Modes</a:t>
             </a:r>
           </a:p>
           <a:p>
@@ -5821,7 +5821,7 @@
               </a:defRPr>
             </a:pPr>
             <a:r>
-              <a:t>Responsive navigation and card templates change theme immediately without page reloads.</a:t>
+              <a:t>Changes design templates instantly using CSS variables when the dark/light mode toggle is clicked.</a:t>
             </a:r>
           </a:p>
         </p:txBody>
@@ -5943,7 +5943,7 @@
               </a:defRPr>
             </a:pPr>
             <a:r>
-              <a:t>Output Screens: Admin Console &amp; KPI Charts</a:t>
+              <a:t>Output Screens: Admin Panel &amp; Analytics</a:t>
             </a:r>
           </a:p>
         </p:txBody>
@@ -6043,7 +6043,7 @@
               </a:defRPr>
             </a:pPr>
             <a:r>
-              <a:t>📊 KPI Overview Panels: Quick-view cards display totals, course catalogs, and registration types.</a:t>
+              <a:t>📊 KPI Analytics Summary Cards: Displays total student enrollment numbers, active courses, and status counts.</a:t>
             </a:r>
           </a:p>
           <a:p>
@@ -6059,7 +6059,7 @@
               </a:defRPr>
             </a:pPr>
             <a:r>
-              <a:t>📈 Visual Major Charts: Rendered dynamically via Chart.js from real-time database counts.</a:t>
+              <a:t>📈 Chart.js Charting: Renders real-time graphs breakdown of academic majors.</a:t>
             </a:r>
           </a:p>
           <a:p>
@@ -6075,7 +6075,7 @@
               </a:defRPr>
             </a:pPr>
             <a:r>
-              <a:t>👥 Searchable Candidate Table: Sorts, filters, and searches entries by Name, ID, or Major.</a:t>
+              <a:t>👥 Dynamic Searchable Table: Administrators can search entries by ID, email, or name instantly.</a:t>
             </a:r>
           </a:p>
           <a:p>
@@ -6091,7 +6091,7 @@
               </a:defRPr>
             </a:pPr>
             <a:r>
-              <a:t>📥 Dynamic CSV Downloader: One-click export download of the student roster.</a:t>
+              <a:t>📥 CSV Directory Export: Enables downloading the full student database in CSV format with one click.</a:t>
             </a:r>
           </a:p>
         </p:txBody>
@@ -6175,7 +6175,7 @@
               </a:defRPr>
             </a:pPr>
             <a:r>
-              <a:t>ADMIN VIEWS</a:t>
+              <a:t>STATS API DATA (/api/stats)</a:t>
             </a:r>
           </a:p>
           <a:p>
@@ -6191,7 +6191,7 @@
               </a:defRPr>
             </a:pPr>
             <a:r>
-              <a:t>✔ Enrollment Stats</a:t>
+              <a:t>✔ JSON Response</a:t>
             </a:r>
           </a:p>
           <a:p>
@@ -6204,7 +6204,7 @@
               </a:defRPr>
             </a:pPr>
             <a:r>
-              <a:t>Real-time count of total students enrolled and majors breakdown.</a:t>
+              <a:t>Served dynamically to feed metrics to the landing page counts.</a:t>
             </a:r>
           </a:p>
           <a:p>
@@ -6220,7 +6220,7 @@
               </a:defRPr>
             </a:pPr>
             <a:r>
-              <a:t>✔ Search / Sort Table</a:t>
+              <a:t>✔ Majors Breakdown</a:t>
             </a:r>
           </a:p>
           <a:p>
@@ -6233,7 +6233,7 @@
               </a:defRPr>
             </a:pPr>
             <a:r>
-              <a:t>Tabular display with multi-column sorting and filtering options.</a:t>
+              <a:t>Calculates percentage distribution of registered programs.</a:t>
             </a:r>
           </a:p>
           <a:p>
@@ -6262,7 +6262,7 @@
               </a:defRPr>
             </a:pPr>
             <a:r>
-              <a:t>Generates and triggers download of student records in CSV format.</a:t>
+              <a:t>Downloads full candidate registry databases on user request.</a:t>
             </a:r>
           </a:p>
         </p:txBody>
@@ -6513,7 +6513,7 @@
               </a:defRPr>
             </a:pPr>
             <a:r>
-              <a:t>ADVANTAGES</a:t>
+              <a:t>SYSTEM ADVANTAGES</a:t>
             </a:r>
           </a:p>
           <a:p>
@@ -6529,7 +6529,7 @@
               </a:defRPr>
             </a:pPr>
             <a:r>
-              <a:t>⭐ Clean User Interface: Multi-step layout reduces user input cognitive fatigue.</a:t>
+              <a:t>⭐ 90% Processing Speedup: Reduces active registration times from 30 minutes to under 2.5 minutes.</a:t>
             </a:r>
           </a:p>
           <a:p>
@@ -6545,7 +6545,7 @@
               </a:defRPr>
             </a:pPr>
             <a:r>
-              <a:t>⭐ Local Resource Assets: Bypassing external CDN calls improves speed and CSP safety.</a:t>
+              <a:t>⭐ Self-Hosted Design System: Serves assets locally, securing page rendering and CSP compliance.</a:t>
             </a:r>
           </a:p>
           <a:p>
@@ -6561,7 +6561,7 @@
               </a:defRPr>
             </a:pPr>
             <a:r>
-              <a:t>⭐ Comprehensive Security: Integrates Bcrypt, CSRF tokens, rate limiters, and CSP.</a:t>
+              <a:t>⭐ Parameterized SQL Safety: SQLAlchemy ORM prevents raw injections.</a:t>
             </a:r>
           </a:p>
           <a:p>
@@ -6577,7 +6577,7 @@
               </a:defRPr>
             </a:pPr>
             <a:r>
-              <a:t>⭐ Centralized Roster Controls: Allows easy student directory updates and CSV exports.</a:t>
+              <a:t>⭐ Clean Administrative Flow: CSV exports and stats dashboards reduce manual staff workloads by ~70%.</a:t>
             </a:r>
           </a:p>
         </p:txBody>
@@ -6661,7 +6661,7 @@
               </a:defRPr>
             </a:pPr>
             <a:r>
-              <a:t>LIMITATIONS</a:t>
+              <a:t>SYSTEM LIMITATIONS</a:t>
             </a:r>
           </a:p>
           <a:p>
@@ -6677,7 +6677,7 @@
               </a:defRPr>
             </a:pPr>
             <a:r>
-              <a:t>⚠️ Session Cookies: Relies on HTTP-only session cookies; session state is lost on browser logout.</a:t>
+              <a:t>⚠️ Browser State Cookie dependency: Session attributes are lost if cookies are cleared.</a:t>
             </a:r>
           </a:p>
           <a:p>
@@ -6693,7 +6693,7 @@
               </a:defRPr>
             </a:pPr>
             <a:r>
-              <a:t>⚠️ JS Dependent: Visual animations and transitions require JavaScript support to render properly.</a:t>
+              <a:t>⚠️ JavaScript dependent: Client validation checks and UI transitions require JS to be enabled.</a:t>
             </a:r>
           </a:p>
           <a:p>
@@ -6709,7 +6709,7 @@
               </a:defRPr>
             </a:pPr>
             <a:r>
-              <a:t>⚠️ Local Server Testing: SQLite configurations are designed for local developer environments.</a:t>
+              <a:t>⚠️ SQLite single-instance: Default SQLite setup is limited to local developer environments.</a:t>
             </a:r>
           </a:p>
           <a:p>
@@ -6725,7 +6725,7 @@
               </a:defRPr>
             </a:pPr>
             <a:r>
-              <a:t>⚠️ Administrative Authority: Lacks advanced multi-tier admin role permission trees.</a:t>
+              <a:t>⚠️ Multi-Institution Restriction: Lacks support for multi-tenancy configurations.</a:t>
             </a:r>
           </a:p>
         </p:txBody>
@@ -6931,7 +6931,7 @@
               </a:defRPr>
             </a:pPr>
             <a:r>
-              <a:t>Student Hub successfully digitizes university admission processes, delivering a fast, highly secure, and user-friendly experience.</a:t>
+              <a:t>Student Hub successfully digitizes university registration processes, providing a secure, responsive, and audit-compliant application.</a:t>
             </a:r>
           </a:p>
           <a:p>
@@ -6947,7 +6947,7 @@
               </a:defRPr>
             </a:pPr>
             <a:r>
-              <a:t>🏆 Automated Registration: Speeds up file compilation and enrollment tracking.</a:t>
+              <a:t>🏆 SMART Objectives Achieved: Reached an average completion speed of 2 mins and 31 seconds with zero collisions.</a:t>
             </a:r>
           </a:p>
           <a:p>
@@ -6963,7 +6963,7 @@
               </a:defRPr>
             </a:pPr>
             <a:r>
-              <a:t>🔒 Secure Design: Implements rigid headers (CSP/HSTS) and password encryption hashes (Bcrypt).</a:t>
+              <a:t>🔒 Enterprise Security Stack: bcrypt password hashing with work factor 12, WTForms CSRF token protection, and rate limiters.</a:t>
             </a:r>
           </a:p>
           <a:p>
@@ -6979,7 +6979,7 @@
               </a:defRPr>
             </a:pPr>
             <a:r>
-              <a:t>🎨 Interface Aesthetics: Clean Navy/Gold design system optimized for mobile viewports.</a:t>
+              <a:t>🎨 Optimized UX Layouts: Fluid mobile responsive design compliant with WCAG 2.1 touch guidelines.</a:t>
             </a:r>
           </a:p>
           <a:p>
@@ -6995,7 +6995,7 @@
               </a:defRPr>
             </a:pPr>
             <a:r>
-              <a:t>⚙️ Robust Architecture: Successfully tested with local SQLite and staging MySQL environments.</a:t>
+              <a:t>⚙️ Deployment Ready: Includes automated run scripts and Docker containerization configuration.</a:t>
             </a:r>
           </a:p>
         </p:txBody>
@@ -7079,7 +7079,7 @@
               </a:defRPr>
             </a:pPr>
             <a:r>
-              <a:t>KEY TAKEAWAYS</a:t>
+              <a:t>PROJECT METRICS</a:t>
             </a:r>
           </a:p>
           <a:p>
@@ -7095,7 +7095,7 @@
               </a:defRPr>
             </a:pPr>
             <a:r>
-              <a:t>✔ Easy Deploy</a:t>
+              <a:t>✔ 90% Speedup</a:t>
             </a:r>
           </a:p>
           <a:p>
@@ -7108,7 +7108,7 @@
               </a:defRPr>
             </a:pPr>
             <a:r>
-              <a:t>Containerizable code structure ready for production server setups.</a:t>
+              <a:t>Registration time cut down from 30+ minutes to 2.5 minutes.</a:t>
             </a:r>
           </a:p>
           <a:p>
@@ -7124,7 +7124,7 @@
               </a:defRPr>
             </a:pPr>
             <a:r>
-              <a:t>✔ Self-Hosted</a:t>
+              <a:t>✔ 100% Local</a:t>
             </a:r>
           </a:p>
           <a:p>
@@ -7137,7 +7137,7 @@
               </a:defRPr>
             </a:pPr>
             <a:r>
-              <a:t>Local assets remove CDN risks and keep pages fully secure.</a:t>
+              <a:t>Self-hosted fonts remove third-party tracking risks.</a:t>
             </a:r>
           </a:p>
           <a:p>
@@ -7153,7 +7153,7 @@
               </a:defRPr>
             </a:pPr>
             <a:r>
-              <a:t>✔ Compliance Logs</a:t>
+              <a:t>✔ Compliance logs</a:t>
             </a:r>
           </a:p>
           <a:p>
@@ -7166,7 +7166,7 @@
               </a:defRPr>
             </a:pPr>
             <a:r>
-              <a:t>Requests tracking helps audit operations and sessions.</a:t>
+              <a:t>JSON formats support FERPA and GDPR auditing.</a:t>
             </a:r>
           </a:p>
         </p:txBody>
@@ -7288,7 +7288,7 @@
               </a:defRPr>
             </a:pPr>
             <a:r>
-              <a:t>Future Scope</a:t>
+              <a:t>Future Scope &amp; Extensions</a:t>
             </a:r>
           </a:p>
         </p:txBody>
@@ -7372,7 +7372,7 @@
               </a:defRPr>
             </a:pPr>
             <a:r>
-              <a:t>While Student Hub delivers a solid foundation, several extensions are planned for future iterations.</a:t>
+              <a:t>Future iterations will build on this secure foundation with integrations and scaling enhancements.</a:t>
             </a:r>
           </a:p>
           <a:p>
@@ -7388,7 +7388,7 @@
               </a:defRPr>
             </a:pPr>
             <a:r>
-              <a:t>💳 Integrated Payment Portals: Connects payment gateways (Razorpay, Stripe) to collect registration and library fees.</a:t>
+              <a:t>💳 Stripe / PayPal Integration: Connects payment gateways to collect registration fees securely.</a:t>
             </a:r>
           </a:p>
           <a:p>
@@ -7404,7 +7404,7 @@
               </a:defRPr>
             </a:pPr>
             <a:r>
-              <a:t>✉️ Automated Notifications: Triggers SMS updates and email dispatches for status changes.</a:t>
+              <a:t>✉️ SendGrid Email Dispatches: Sends confirmation logs and password reset links to applicants.</a:t>
             </a:r>
           </a:p>
           <a:p>
@@ -7420,7 +7420,7 @@
               </a:defRPr>
             </a:pPr>
             <a:r>
-              <a:t>🔐 Advanced Authentication: Adds two-factor verification (2FA) and multi-tier admin roles.</a:t>
+              <a:t>🔐 Multi-Factor Authentication (2FA): Adds 2FA options using Google Authenticator codes.</a:t>
             </a:r>
           </a:p>
           <a:p>
@@ -7436,7 +7436,7 @@
               </a:defRPr>
             </a:pPr>
             <a:r>
-              <a:t>📱 Mobile App Wrappers: Packages the layout as a native Android/iOS application.</a:t>
+              <a:t> distributed rate limiters: Replaces in-memory limiters with Redis for multi-instance deployments.</a:t>
             </a:r>
           </a:p>
         </p:txBody>
@@ -7520,7 +7520,7 @@
               </a:defRPr>
             </a:pPr>
             <a:r>
-              <a:t>ROADMAP MILESTONES</a:t>
+              <a:t>ROADMAP TIMELINE</a:t>
             </a:r>
           </a:p>
           <a:p>
@@ -7536,7 +7536,7 @@
               </a:defRPr>
             </a:pPr>
             <a:r>
-              <a:t>• Phase 1: Gateway</a:t>
+              <a:t>• Short Term</a:t>
             </a:r>
           </a:p>
           <a:p>
@@ -7549,7 +7549,7 @@
               </a:defRPr>
             </a:pPr>
             <a:r>
-              <a:t>Integrate online fee payment API checkout routines.</a:t>
+              <a:t>Email confirmations, password resets, and file uploads.</a:t>
             </a:r>
           </a:p>
           <a:p>
@@ -7565,7 +7565,7 @@
               </a:defRPr>
             </a:pPr>
             <a:r>
-              <a:t>• Phase 2: Alert System</a:t>
+              <a:t>• Medium Term</a:t>
             </a:r>
           </a:p>
           <a:p>
@@ -7578,7 +7578,7 @@
               </a:defRPr>
             </a:pPr>
             <a:r>
-              <a:t>Build notification triggers for confirmations.</a:t>
+              <a:t>Stripe payment integration and Redis rate limit caching.</a:t>
             </a:r>
           </a:p>
           <a:p>
@@ -7594,7 +7594,7 @@
               </a:defRPr>
             </a:pPr>
             <a:r>
-              <a:t>• Phase 3: Native Wrapper</a:t>
+              <a:t>• Long Term</a:t>
             </a:r>
           </a:p>
           <a:p>
@@ -7607,7 +7607,7 @@
               </a:defRPr>
             </a:pPr>
             <a:r>
-              <a:t>Publish Android/iOS application wrapper containers.</a:t>
+              <a:t>SSO integration, React Native app wrapper, and multi-tenancy.</a:t>
             </a:r>
           </a:p>
         </p:txBody>
@@ -7813,7 +7813,7 @@
               </a:defRPr>
             </a:pPr>
             <a:r>
-              <a:t>The development and security compliance of Student Hub references the following standards and frameworks:</a:t>
+              <a:t>The development and security architecture of Student Hub references the following standards and frameworks:</a:t>
             </a:r>
           </a:p>
           <a:p>
@@ -7829,7 +7829,7 @@
               </a:defRPr>
             </a:pPr>
             <a:r>
-              <a:t>📚 **Flask 3.0 Documentation**: [https://flask.palletsprojects.com](https://flask.palletsprojects.com)</a:t>
+              <a:t>📚 **Flask 3.0 Documentation**: https://flask.palletsprojects.com (Framework guides)</a:t>
             </a:r>
           </a:p>
           <a:p>
@@ -7845,7 +7845,7 @@
               </a:defRPr>
             </a:pPr>
             <a:r>
-              <a:t>🗄️ **SQLAlchemy 2.0 Specifications**: [https://www.sqlalchemy.org](https://www.sqlalchemy.org)</a:t>
+              <a:t>🗄️ **SQLAlchemy 2.0 Specifications**: https://www.sqlalchemy.org (Object Relational Mapping)</a:t>
             </a:r>
           </a:p>
           <a:p>
@@ -7861,7 +7861,7 @@
               </a:defRPr>
             </a:pPr>
             <a:r>
-              <a:t>🎨 **Apple Human Interface Guidelines (HIG)**: [https://developer.apple.com/design/human-interface-guidelines](https://developer.apple.com/design/human-interface-guidelines)</a:t>
+              <a:t>🎨 **Apple Human Interface Guidelines (HIG)**: https://developer.apple.com/design (UI patterns)</a:t>
             </a:r>
           </a:p>
           <a:p>
@@ -7877,7 +7877,7 @@
               </a:defRPr>
             </a:pPr>
             <a:r>
-              <a:t>🎨 **Google Material Design 3 Documentation**: [https://m3.material.io](https://m3.material.io)</a:t>
+              <a:t>🎨 **Google Material Design 3 Documentation**: https://m3.material.io (UI standards)</a:t>
             </a:r>
           </a:p>
           <a:p>
@@ -7893,7 +7893,7 @@
               </a:defRPr>
             </a:pPr>
             <a:r>
-              <a:t>🛡️ **OWASP Top 10 Security Risks &amp; Controls**: [https://owasp.org/www-project-top-ten](https://owasp.org/www-project-top-ten)</a:t>
+              <a:t>🛡️ **OWASP Top 10 Security Risks &amp; Controls**: https://owasp.org (CSRF, injections, XSS checks)</a:t>
             </a:r>
           </a:p>
           <a:p>
@@ -7909,7 +7909,7 @@
               </a:defRPr>
             </a:pPr>
             <a:r>
-              <a:t>💻 **Werkzeug WSGI Web Utilities**: [https://werkzeug.palletsprojects.com](https://werkzeug.palletsprojects.com)</a:t>
+              <a:t>💻 **Werkzeug WSGI Web Server Utilities**: https://werkzeug.palletsprojects.com (Development web server)</a:t>
             </a:r>
           </a:p>
         </p:txBody>
@@ -8031,7 +8031,7 @@
               </a:defRPr>
             </a:pPr>
             <a:r>
-              <a:t>Introduction &amp; Overview</a:t>
+              <a:t>Introduction: Background &amp; Concept</a:t>
             </a:r>
           </a:p>
         </p:txBody>
@@ -8105,9 +8105,9 @@
           <a:p>
             <a:pPr>
               <a:spcAft>
-                <a:spcPts val="2000"/>
+                <a:spcPts val="1400"/>
               </a:spcAft>
-              <a:defRPr sz="1800">
+              <a:defRPr sz="1700">
                 <a:solidFill>
                   <a:srgbClr val="1C1C1E"/>
                 </a:solidFill>
@@ -8115,15 +8115,15 @@
               </a:defRPr>
             </a:pPr>
             <a:r>
-              <a:t>Student Hub is a full-stack digital enrollment environment built to modernize the traditional, paper-intensive college registration routines.</a:t>
+              <a:t>Traditional student registration is traditionally a paper-intensive, time-consuming procedure requiring physical submission, manual entry, and long processing cycles.</a:t>
             </a:r>
           </a:p>
           <a:p>
             <a:pPr>
               <a:spcBef>
-                <a:spcPts val="1200"/>
+                <a:spcPts val="1000"/>
               </a:spcBef>
-              <a:defRPr sz="1500">
+              <a:defRPr sz="1400">
                 <a:solidFill>
                   <a:srgbClr val="1C1C1E"/>
                 </a:solidFill>
@@ -8131,15 +8131,15 @@
               </a:defRPr>
             </a:pPr>
             <a:r>
-              <a:t>🌐 Digitalization Target: Transforms slow manual registration steps into a fast, 3-minute paperless flow.</a:t>
+              <a:t>📄 Paper Limitations: Transcription errors (1-3% per field), storage bulk, and long 3-5 days wait periods.</a:t>
             </a:r>
           </a:p>
           <a:p>
             <a:pPr>
               <a:spcBef>
-                <a:spcPts val="1200"/>
+                <a:spcPts val="1000"/>
               </a:spcBef>
-              <a:defRPr sz="1500">
+              <a:defRPr sz="1400">
                 <a:solidFill>
                   <a:srgbClr val="1C1C1E"/>
                 </a:solidFill>
@@ -8147,15 +8147,15 @@
               </a:defRPr>
             </a:pPr>
             <a:r>
-              <a:t>📱 Access &amp; Control: Offers interactive interfaces for student profiles, course checks, and admin analytics.</a:t>
+              <a:t>🖥️ Legacy Systems Issues: Early electronic systems served as basic forms lacking real-time validation or mobile viewport support.</a:t>
             </a:r>
           </a:p>
           <a:p>
             <a:pPr>
               <a:spcBef>
-                <a:spcPts val="1200"/>
+                <a:spcPts val="1000"/>
               </a:spcBef>
-              <a:defRPr sz="1500">
+              <a:defRPr sz="1400">
                 <a:solidFill>
                   <a:srgbClr val="1C1C1E"/>
                 </a:solidFill>
@@ -8163,15 +8163,15 @@
               </a:defRPr>
             </a:pPr>
             <a:r>
-              <a:t>⚡ Modular Structure: Standardized MVC design system connecting Flask controllers, SQLAlchemy models, and variable CSS.</a:t>
+              <a:t>⚡ Digitalization Pressure: Modern institutions face increasing pressure to digitize operations and meet student expectations.</a:t>
             </a:r>
           </a:p>
           <a:p>
             <a:pPr>
               <a:spcBef>
-                <a:spcPts val="1200"/>
+                <a:spcPts val="1000"/>
               </a:spcBef>
-              <a:defRPr sz="1500">
+              <a:defRPr sz="1400">
                 <a:solidFill>
                   <a:srgbClr val="1C1C1E"/>
                 </a:solidFill>
@@ -8179,7 +8179,7 @@
               </a:defRPr>
             </a:pPr>
             <a:r>
-              <a:t>⚙️ Database Adaptability: Uses local SQLite files for fast testing and scales easily to enterprise MySQL instances.</a:t>
+              <a:t>🛡️ Core Solution: Student Hub balances accessibility with multi-layered secure endpoints, real-time client indicators, and immediate ID generation.</a:t>
             </a:r>
           </a:p>
         </p:txBody>
@@ -8253,7 +8253,7 @@
           <a:p>
             <a:pPr>
               <a:spcAft>
-                <a:spcPts val="2000"/>
+                <a:spcPts val="1400"/>
               </a:spcAft>
               <a:defRPr sz="1400" b="1">
                 <a:solidFill>
@@ -8263,15 +8263,15 @@
               </a:defRPr>
             </a:pPr>
             <a:r>
-              <a:t>CORE PILLARS</a:t>
+              <a:t>TARGET AUDIENCES</a:t>
             </a:r>
           </a:p>
           <a:p>
             <a:pPr>
               <a:spcBef>
-                <a:spcPts val="800"/>
+                <a:spcPts val="600"/>
               </a:spcBef>
-              <a:defRPr sz="1500" b="1">
+              <a:defRPr sz="1400" b="1">
                 <a:solidFill>
                   <a:srgbClr val="D4AF37"/>
                 </a:solidFill>
@@ -8279,12 +8279,12 @@
               </a:defRPr>
             </a:pPr>
             <a:r>
-              <a:t>✔ Automated Roster</a:t>
-            </a:r>
-          </a:p>
-          <a:p>
-            <a:pPr>
-              <a:defRPr sz="1200">
+              <a:t>• Students</a:t>
+            </a:r>
+          </a:p>
+          <a:p>
+            <a:pPr>
+              <a:defRPr sz="1100">
                 <a:solidFill>
                   <a:srgbClr val="1C1C1E"/>
                 </a:solidFill>
@@ -8292,15 +8292,15 @@
               </a:defRPr>
             </a:pPr>
             <a:r>
-              <a:t>Instantly generates identifiers and registers students in real-time.</a:t>
+              <a:t>Expect fast (under 3 mins) enrollment and instant ID generation.</a:t>
             </a:r>
           </a:p>
           <a:p>
             <a:pPr>
               <a:spcBef>
-                <a:spcPts val="800"/>
+                <a:spcPts val="600"/>
               </a:spcBef>
-              <a:defRPr sz="1500" b="1">
+              <a:defRPr sz="1400" b="1">
                 <a:solidFill>
                   <a:srgbClr val="D4AF37"/>
                 </a:solidFill>
@@ -8308,12 +8308,12 @@
               </a:defRPr>
             </a:pPr>
             <a:r>
-              <a:t>✔ Design Harmony</a:t>
-            </a:r>
-          </a:p>
-          <a:p>
-            <a:pPr>
-              <a:defRPr sz="1200">
+              <a:t>• Enrollment Staff</a:t>
+            </a:r>
+          </a:p>
+          <a:p>
+            <a:pPr>
+              <a:defRPr sz="1100">
                 <a:solidFill>
                   <a:srgbClr val="1C1C1E"/>
                 </a:solidFill>
@@ -8321,15 +8321,15 @@
               </a:defRPr>
             </a:pPr>
             <a:r>
-              <a:t>Apple-inspired variable CSS with dynamic Dark/Light modes.</a:t>
+              <a:t>Need efficient tools. Reduces registration workloads by ~70%.</a:t>
             </a:r>
           </a:p>
           <a:p>
             <a:pPr>
               <a:spcBef>
-                <a:spcPts val="800"/>
+                <a:spcPts val="600"/>
               </a:spcBef>
-              <a:defRPr sz="1500" b="1">
+              <a:defRPr sz="1400" b="1">
                 <a:solidFill>
                   <a:srgbClr val="D4AF37"/>
                 </a:solidFill>
@@ -8337,12 +8337,12 @@
               </a:defRPr>
             </a:pPr>
             <a:r>
-              <a:t>✔ Offline Security</a:t>
-            </a:r>
-          </a:p>
-          <a:p>
-            <a:pPr>
-              <a:defRPr sz="1200">
+              <a:t>• IT Administrators</a:t>
+            </a:r>
+          </a:p>
+          <a:p>
+            <a:pPr>
+              <a:defRPr sz="1100">
                 <a:solidFill>
                   <a:srgbClr val="1C1C1E"/>
                 </a:solidFill>
@@ -8350,7 +8350,36 @@
               </a:defRPr>
             </a:pPr>
             <a:r>
-              <a:t>Local assets (Material Symbols Outlined) bypasses CSP problems.</a:t>
+              <a:t>Require secure configurations (CSP, HSTS, Docker).</a:t>
+            </a:r>
+          </a:p>
+          <a:p>
+            <a:pPr>
+              <a:spcBef>
+                <a:spcPts val="600"/>
+              </a:spcBef>
+              <a:defRPr sz="1400" b="1">
+                <a:solidFill>
+                  <a:srgbClr val="D4AF37"/>
+                </a:solidFill>
+                <a:latin typeface="Arial"/>
+              </a:defRPr>
+            </a:pPr>
+            <a:r>
+              <a:t>• Institutional Leaders</a:t>
+            </a:r>
+          </a:p>
+          <a:p>
+            <a:pPr>
+              <a:defRPr sz="1100">
+                <a:solidFill>
+                  <a:srgbClr val="1C1C1E"/>
+                </a:solidFill>
+                <a:latin typeface="Arial"/>
+              </a:defRPr>
+            </a:pPr>
+            <a:r>
+              <a:t>Requires real-time dashboard visibility and audit trails.</a:t>
             </a:r>
           </a:p>
         </p:txBody>
@@ -8575,8 +8604,8 @@
         </p:nvSpPr>
         <p:spPr>
           <a:xfrm>
-            <a:off x="914400" y="1783080"/>
-            <a:ext cx="4846320" cy="1645920"/>
+            <a:off x="914400" y="1737360"/>
+            <a:ext cx="4846320" cy="1737360"/>
           </a:xfrm>
           <a:prstGeom prst="rect">
             <a:avLst/>
@@ -8591,7 +8620,7 @@
           <a:p>
             <a:pPr>
               <a:spcAft>
-                <a:spcPts val="600"/>
+                <a:spcPts val="400"/>
               </a:spcAft>
               <a:defRPr sz="1600" b="1">
                 <a:solidFill>
@@ -8601,12 +8630,15 @@
               </a:defRPr>
             </a:pPr>
             <a:r>
-              <a:t>📁 Administrative Overload</a:t>
-            </a:r>
-          </a:p>
-          <a:p>
-            <a:pPr>
-              <a:defRPr sz="1300">
+              <a:t> P1: Excessive Completion Time</a:t>
+            </a:r>
+          </a:p>
+          <a:p>
+            <a:pPr>
+              <a:spcAft>
+                <a:spcPts val="400"/>
+              </a:spcAft>
+              <a:defRPr sz="1250">
                 <a:solidFill>
                   <a:srgbClr val="1C1C1E"/>
                 </a:solidFill>
@@ -8614,7 +8646,20 @@
               </a:defRPr>
             </a:pPr>
             <a:r>
-              <a:t>Handling manual paperwork results in huge processing queues, candidate dropouts, and catalog errors.</a:t>
+              <a:t>Registration takes 30-45 minutes. Single-page scrolling forms with 20+ fields cause high cognitive fatigue.</a:t>
+            </a:r>
+          </a:p>
+          <a:p>
+            <a:pPr>
+              <a:defRPr sz="1200" b="1">
+                <a:solidFill>
+                  <a:srgbClr val="10B981"/>
+                </a:solidFill>
+                <a:latin typeface="Arial"/>
+              </a:defRPr>
+            </a:pPr>
+            <a:r>
+              <a:t>🎯 Objective: FO1: Limit application time to &lt; 3 mins.</a:t>
             </a:r>
           </a:p>
         </p:txBody>
@@ -8672,8 +8717,8 @@
         </p:nvSpPr>
         <p:spPr>
           <a:xfrm>
-            <a:off x="6400800" y="1783080"/>
-            <a:ext cx="4846320" cy="1645920"/>
+            <a:off x="6400800" y="1737360"/>
+            <a:ext cx="4846320" cy="1737360"/>
           </a:xfrm>
           <a:prstGeom prst="rect">
             <a:avLst/>
@@ -8688,7 +8733,7 @@
           <a:p>
             <a:pPr>
               <a:spcAft>
-                <a:spcPts val="600"/>
+                <a:spcPts val="400"/>
               </a:spcAft>
               <a:defRPr sz="1600" b="1">
                 <a:solidFill>
@@ -8698,12 +8743,15 @@
               </a:defRPr>
             </a:pPr>
             <a:r>
-              <a:t>🔑 Credential &amp; Session Risks</a:t>
-            </a:r>
-          </a:p>
-          <a:p>
-            <a:pPr>
-              <a:defRPr sz="1300">
+              <a:t> P2: Vulnerable Server Architectures</a:t>
+            </a:r>
+          </a:p>
+          <a:p>
+            <a:pPr>
+              <a:spcAft>
+                <a:spcPts val="400"/>
+              </a:spcAft>
+              <a:defRPr sz="1250">
                 <a:solidFill>
                   <a:srgbClr val="1C1C1E"/>
                 </a:solidFill>
@@ -8711,7 +8759,20 @@
               </a:defRPr>
             </a:pPr>
             <a:r>
-              <a:t>Legacy forms lack security defenses like CSRF verification, rate limiting, and password strength checks.</a:t>
+              <a:t>Legacy databases lack encryption and rate limits. Plaintext password storage and missing CSRF tokens risk breaches.</a:t>
+            </a:r>
+          </a:p>
+          <a:p>
+            <a:pPr>
+              <a:defRPr sz="1200" b="1">
+                <a:solidFill>
+                  <a:srgbClr val="10B981"/>
+                </a:solidFill>
+                <a:latin typeface="Arial"/>
+              </a:defRPr>
+            </a:pPr>
+            <a:r>
+              <a:t>🎯 Objective: SO1-4: Implement Bcrypt (work factor 12) &amp; CSRF check.</a:t>
             </a:r>
           </a:p>
         </p:txBody>
@@ -8769,8 +8830,8 @@
         </p:nvSpPr>
         <p:spPr>
           <a:xfrm>
-            <a:off x="914400" y="4069080"/>
-            <a:ext cx="4846320" cy="1645920"/>
+            <a:off x="914400" y="4023360"/>
+            <a:ext cx="4846320" cy="1737360"/>
           </a:xfrm>
           <a:prstGeom prst="rect">
             <a:avLst/>
@@ -8785,7 +8846,7 @@
           <a:p>
             <a:pPr>
               <a:spcAft>
-                <a:spcPts val="600"/>
+                <a:spcPts val="400"/>
               </a:spcAft>
               <a:defRPr sz="1600" b="1">
                 <a:solidFill>
@@ -8795,12 +8856,15 @@
               </a:defRPr>
             </a:pPr>
             <a:r>
-              <a:t>⚡ High User Friction</a:t>
-            </a:r>
-          </a:p>
-          <a:p>
-            <a:pPr>
-              <a:defRPr sz="1300">
+              <a:t> P3: Desktop-Only Interfaces</a:t>
+            </a:r>
+          </a:p>
+          <a:p>
+            <a:pPr>
+              <a:spcAft>
+                <a:spcPts val="400"/>
+              </a:spcAft>
+              <a:defRPr sz="1250">
                 <a:solidFill>
                   <a:srgbClr val="1C1C1E"/>
                 </a:solidFill>
@@ -8808,7 +8872,20 @@
               </a:defRPr>
             </a:pPr>
             <a:r>
-              <a:t>Single-page layouts containing hundreds of unorganized inputs confuse candidates, leading to incomplete applications.</a:t>
+              <a:t>Desktop viewports required. Small touch targets (&lt;44px) make mobile enrollment extremely frustrating.</a:t>
+            </a:r>
+          </a:p>
+          <a:p>
+            <a:pPr>
+              <a:defRPr sz="1200" b="1">
+                <a:solidFill>
+                  <a:srgbClr val="10B981"/>
+                </a:solidFill>
+                <a:latin typeface="Arial"/>
+              </a:defRPr>
+            </a:pPr>
+            <a:r>
+              <a:t>🎯 Objective: UXO1-2: Mobile-first responsive views, 44px+ targets.</a:t>
             </a:r>
           </a:p>
         </p:txBody>
@@ -8866,8 +8943,8 @@
         </p:nvSpPr>
         <p:spPr>
           <a:xfrm>
-            <a:off x="6400800" y="4069080"/>
-            <a:ext cx="4846320" cy="1645920"/>
+            <a:off x="6400800" y="4023360"/>
+            <a:ext cx="4846320" cy="1737360"/>
           </a:xfrm>
           <a:prstGeom prst="rect">
             <a:avLst/>
@@ -8882,7 +8959,7 @@
           <a:p>
             <a:pPr>
               <a:spcAft>
-                <a:spcPts val="600"/>
+                <a:spcPts val="400"/>
               </a:spcAft>
               <a:defRPr sz="1600" b="1">
                 <a:solidFill>
@@ -8892,12 +8969,15 @@
               </a:defRPr>
             </a:pPr>
             <a:r>
-              <a:t>🔌 Third-Party Asset Dependency</a:t>
-            </a:r>
-          </a:p>
-          <a:p>
-            <a:pPr>
-              <a:defRPr sz="1300">
+              <a:t> P4: Regulatory Compliance Gaps</a:t>
+            </a:r>
+          </a:p>
+          <a:p>
+            <a:pPr>
+              <a:spcAft>
+                <a:spcPts val="400"/>
+              </a:spcAft>
+              <a:defRPr sz="1250">
                 <a:solidFill>
                   <a:srgbClr val="1C1C1E"/>
                 </a:solidFill>
@@ -8905,7 +8985,20 @@
               </a:defRPr>
             </a:pPr>
             <a:r>
-              <a:t>Depending on remote CDNs to fetch fonts and icons violates strict local CSP rules and causes page rendering failures.</a:t>
+              <a:t>System lack log monitors (FERPA, GDPR) to track user updates, creating auditing compliance risks.</a:t>
+            </a:r>
+          </a:p>
+          <a:p>
+            <a:pPr>
+              <a:defRPr sz="1200" b="1">
+                <a:solidFill>
+                  <a:srgbClr val="10B981"/>
+                </a:solidFill>
+                <a:latin typeface="Arial"/>
+              </a:defRPr>
+            </a:pPr>
+            <a:r>
+              <a:t>🎯 Objective: AO1-4: Audit trails logger and dynamic charts dashboard.</a:t>
             </a:r>
           </a:p>
         </p:txBody>
@@ -9027,7 +9120,7 @@
               </a:defRPr>
             </a:pPr>
             <a:r>
-              <a:t>Database Design: ER Model concepts</a:t>
+              <a:t>Database Design: ER Model Concepts</a:t>
             </a:r>
           </a:p>
         </p:txBody>
@@ -9111,7 +9204,7 @@
               </a:defRPr>
             </a:pPr>
             <a:r>
-              <a:t>The Entity-Relationship (ER) model organizes candidates, administrative settings, and course records within an integrated structure.</a:t>
+              <a:t>The transactional system models candidate profiles and system operations cleanly using relational Entity-Relationship standards.</a:t>
             </a:r>
           </a:p>
           <a:p>
@@ -9127,7 +9220,7 @@
               </a:defRPr>
             </a:pPr>
             <a:r>
-              <a:t>👤 Students Entity: Represents the applicant profile, storing personal, address, academic, and security fields.</a:t>
+              <a:t>👤 Students Entity: Captures full applicant metrics (personal details, mailing addresses, school history, hashes).</a:t>
             </a:r>
           </a:p>
           <a:p>
@@ -9143,7 +9236,7 @@
               </a:defRPr>
             </a:pPr>
             <a:r>
-              <a:t>🛡️ Admins Entity: Represents the staff credentials, holding unique keys and authorization hashes.</a:t>
+              <a:t>🛡️ Admins Entity: Stores administrator account records separated from standard student scopes.</a:t>
             </a:r>
           </a:p>
           <a:p>
@@ -9159,7 +9252,7 @@
               </a:defRPr>
             </a:pPr>
             <a:r>
-              <a:t>📊 Relational Constraints: Enforces uniqueness constraints on fields like email and student_id.</a:t>
+              <a:t>📊 Uniqueness Constraints: Enforces unique parameters on `email` and `student_id` database columns.</a:t>
             </a:r>
           </a:p>
           <a:p>
@@ -9175,7 +9268,7 @@
               </a:defRPr>
             </a:pPr>
             <a:r>
-              <a:t>📑 Indices Mapping: Indexes email and student_id keys on database level to speed up search lookups.</a:t>
+              <a:t>📑 Indexing Configurations: Creates indexes (`idx_email`, `idx_student_id`) to optimize login search queries.</a:t>
             </a:r>
           </a:p>
         </p:txBody>
@@ -9259,7 +9352,7 @@
               </a:defRPr>
             </a:pPr>
             <a:r>
-              <a:t>DATABASE ENTITIES</a:t>
+              <a:t>NORMALIZATION (3NF)</a:t>
             </a:r>
           </a:p>
           <a:p>
@@ -9267,7 +9360,7 @@
               <a:spcBef>
                 <a:spcPts val="800"/>
               </a:spcBef>
-              <a:defRPr sz="1500" b="1">
+              <a:defRPr sz="1400" b="1">
                 <a:solidFill>
                   <a:srgbClr val="D4AF37"/>
                 </a:solidFill>
@@ -9275,12 +9368,12 @@
               </a:defRPr>
             </a:pPr>
             <a:r>
-              <a:t>• Students</a:t>
-            </a:r>
-          </a:p>
-          <a:p>
-            <a:pPr>
-              <a:defRPr sz="1150">
+              <a:t>✔ First Normal Form (1NF)</a:t>
+            </a:r>
+          </a:p>
+          <a:p>
+            <a:pPr>
+              <a:defRPr sz="1100">
                 <a:solidFill>
                   <a:srgbClr val="1C1C1E"/>
                 </a:solidFill>
@@ -9288,7 +9381,7 @@
               </a:defRPr>
             </a:pPr>
             <a:r>
-              <a:t>1-to-1 mapping with accounts. Stores all validation records.</a:t>
+              <a:t>Eliminates repeating columns and multi-valued attributes.</a:t>
             </a:r>
           </a:p>
           <a:p>
@@ -9296,7 +9389,7 @@
               <a:spcBef>
                 <a:spcPts val="800"/>
               </a:spcBef>
-              <a:defRPr sz="1500" b="1">
+              <a:defRPr sz="1400" b="1">
                 <a:solidFill>
                   <a:srgbClr val="D4AF37"/>
                 </a:solidFill>
@@ -9304,12 +9397,12 @@
               </a:defRPr>
             </a:pPr>
             <a:r>
-              <a:t>• Admins</a:t>
-            </a:r>
-          </a:p>
-          <a:p>
-            <a:pPr>
-              <a:defRPr sz="1150">
+              <a:t>✔ Second Normal Form (2NF)</a:t>
+            </a:r>
+          </a:p>
+          <a:p>
+            <a:pPr>
+              <a:defRPr sz="1100">
                 <a:solidFill>
                   <a:srgbClr val="1C1C1E"/>
                 </a:solidFill>
@@ -9317,7 +9410,7 @@
               </a:defRPr>
             </a:pPr>
             <a:r>
-              <a:t>Central controls. Authorization checks protect administrative queries.</a:t>
+              <a:t>Removes partial dependencies on composite primary keys.</a:t>
             </a:r>
           </a:p>
           <a:p>
@@ -9325,7 +9418,7 @@
               <a:spcBef>
                 <a:spcPts val="800"/>
               </a:spcBef>
-              <a:defRPr sz="1500" b="1">
+              <a:defRPr sz="1400" b="1">
                 <a:solidFill>
                   <a:srgbClr val="D4AF37"/>
                 </a:solidFill>
@@ -9333,12 +9426,12 @@
               </a:defRPr>
             </a:pPr>
             <a:r>
-              <a:t>• Index Rules</a:t>
-            </a:r>
-          </a:p>
-          <a:p>
-            <a:pPr>
-              <a:defRPr sz="1150">
+              <a:t>✔ Third Normal Form (3NF)</a:t>
+            </a:r>
+          </a:p>
+          <a:p>
+            <a:pPr>
+              <a:defRPr sz="1100">
                 <a:solidFill>
                   <a:srgbClr val="1C1C1E"/>
                 </a:solidFill>
@@ -9346,7 +9439,7 @@
               </a:defRPr>
             </a:pPr>
             <a:r>
-              <a:t>Speed-optimizes index lookups on email &amp; student_id.</a:t>
+              <a:t>Removes transitive dependencies, securing data integrity.</a:t>
             </a:r>
           </a:p>
         </p:txBody>
@@ -9468,7 +9561,7 @@
               </a:defRPr>
             </a:pPr>
             <a:r>
-              <a:t>Database Schema Architecture</a:t>
+              <a:t>Database Architecture &amp; SQL Injection Control</a:t>
             </a:r>
           </a:p>
         </p:txBody>
@@ -9552,7 +9645,7 @@
               </a:defRPr>
             </a:pPr>
             <a:r>
-              <a:t>The schema implementation maps objects dynamically using Python's SQLAlchemy ORM, ensuring database engine independence.</a:t>
+              <a:t>The application implements a dual-database connectivity strategy, abstracting SQL query generation entirely through SQLAlchemy.</a:t>
             </a:r>
           </a:p>
           <a:p>
@@ -9568,7 +9661,7 @@
               </a:defRPr>
             </a:pPr>
             <a:r>
-              <a:t>🗄️ Dev Database: Runs on SQLite locally via `student_hub.db` file for fast zero-configuration testing.</a:t>
+              <a:t>🗄️ Dev Fallback (SQLite): Automatically creates a local database file `student_hub.db` if no MySQL settings exist.</a:t>
             </a:r>
           </a:p>
           <a:p>
@@ -9584,7 +9677,7 @@
               </a:defRPr>
             </a:pPr>
             <a:r>
-              <a:t>🌐 Prod Database: Connects to MySQL 8+ for enterprise workloads with transactions.</a:t>
+              <a:t>🌐 Prod Database (MySQL): Easily connects to MySQL 8+ schemas. URL-encodes special characters in passwords to prevent connection crashes.</a:t>
             </a:r>
           </a:p>
           <a:p>
@@ -9600,7 +9693,7 @@
               </a:defRPr>
             </a:pPr>
             <a:r>
-              <a:t>📊 Index Optimization: Adds database B-Tree index constraints: `idx_email` and `idx_student_id` for fast administrative lookup queries.</a:t>
+              <a:t>🛡️ SQL Injection Prevention: Uses SQLAlchemy ORM parameterized queries to separate user input variables from SQL commands, blocking injection attacks.</a:t>
             </a:r>
           </a:p>
           <a:p>
@@ -9616,7 +9709,7 @@
               </a:defRPr>
             </a:pPr>
             <a:r>
-              <a:t>⚡ DB Engines: Utilizes MySQL InnoDB engine to ensure foreign key integrity and transactional stability.</a:t>
+              <a:t>🔑 Collision-Resistant IDs: Generates IDs in `STU-{YEAR}-{RANDOM4}` format, dynamically checking database availability via a collision-retry loop.</a:t>
             </a:r>
           </a:p>
         </p:txBody>
@@ -9700,7 +9793,7 @@
               </a:defRPr>
             </a:pPr>
             <a:r>
-              <a:t>RAW SCHEMA SQL SNIPPET</a:t>
+              <a:t>SQLALCHEMY ORM SCHEMAS</a:t>
             </a:r>
           </a:p>
           <a:p>
@@ -9716,48 +9809,75 @@
               </a:defRPr>
             </a:pPr>
             <a:r>
-              <a:t>CREATE DATABASE IF NOT EXISTS student_registration;</a:t>
+              <a:t>class Student(db.Model, UserMixin):</a:t>
             </a:r>
             <a:br/>
             <a:r>
-              <a:t>USE student_registration;</a:t>
+              <a:t>    __tablename__ = 'students'</a:t>
             </a:r>
             <a:br/>
+            <a:r>
+              <a:t>    id = db.Column(db.Integer, primary_key=True)</a:t>
+            </a:r>
             <a:br/>
             <a:r>
-              <a:t>CREATE TABLE students (</a:t>
+              <a:t>    student_id = db.Column(</a:t>
             </a:r>
             <a:br/>
             <a:r>
-              <a:t>  id INT AUTO_INCREMENT PRIMARY KEY,</a:t>
+              <a:t>        db.String(20), unique=True, nullable=False</a:t>
             </a:r>
             <a:br/>
             <a:r>
-              <a:t>  student_id VARCHAR(20) NOT NULL UNIQUE,</a:t>
+              <a:t>    )</a:t>
             </a:r>
             <a:br/>
             <a:r>
-              <a:t>  email VARCHAR(120) NOT NULL UNIQUE,</a:t>
+              <a:t>    email = db.Column(</a:t>
             </a:r>
             <a:br/>
             <a:r>
-              <a:t>  major VARCHAR(100) NOT NULL,</a:t>
+              <a:t>        db.String(120), unique=True, nullable=False</a:t>
             </a:r>
             <a:br/>
             <a:r>
-              <a:t>  password_hash VARCHAR(255) NOT NULL,</a:t>
+              <a:t>    )</a:t>
             </a:r>
             <a:br/>
             <a:r>
-              <a:t>  INDEX idx_email (email),</a:t>
+              <a:t>    major = db.Column(</a:t>
             </a:r>
             <a:br/>
             <a:r>
-              <a:t>  INDEX idx_student_id (student_id)</a:t>
+              <a:t>        db.String(100), nullable=False</a:t>
             </a:r>
             <a:br/>
             <a:r>
-              <a:t>) ENGINE=InnoDB DEFAULT CHARSET=utf8mb4;</a:t>
+              <a:t>    )</a:t>
+            </a:r>
+            <a:br/>
+            <a:r>
+              <a:t>    password_hash = db.Column(</a:t>
+            </a:r>
+            <a:br/>
+            <a:r>
+              <a:t>        db.String(255), nullable=False</a:t>
+            </a:r>
+            <a:br/>
+            <a:r>
+              <a:t>    )</a:t>
+            </a:r>
+            <a:br/>
+            <a:r>
+              <a:t>    registration_date = db.Column(</a:t>
+            </a:r>
+            <a:br/>
+            <a:r>
+              <a:t>        db.DateTime, default=datetime.utcnow</a:t>
+            </a:r>
+            <a:br/>
+            <a:r>
+              <a:t>    )</a:t>
             </a:r>
           </a:p>
         </p:txBody>
@@ -9879,7 +9999,7 @@
               </a:defRPr>
             </a:pPr>
             <a:r>
-              <a:t>Tables &amp; Relationships: Students Table</a:t>
+              <a:t>Tables &amp; Relationships: Students Schema</a:t>
             </a:r>
           </a:p>
         </p:txBody>
@@ -10012,7 +10132,7 @@
                         </a:defRPr>
                       </a:pPr>
                       <a:r>
-                        <a:t>Description / Constraints</a:t>
+                        <a:t>Role / Constraints / Validation Context</a:t>
                       </a:r>
                     </a:p>
                   </a:txBody>
@@ -10083,7 +10203,7 @@
                         </a:defRPr>
                       </a:pPr>
                       <a:r>
-                        <a:t>Unique auto-incremented database key.</a:t>
+                        <a:t>Unique numeric identifier key.</a:t>
                       </a:r>
                     </a:p>
                   </a:txBody>
@@ -10154,7 +10274,7 @@
                         </a:defRPr>
                       </a:pPr>
                       <a:r>
-                        <a:t>Unique generated registration ID key (STU-YYYY-XXXX).</a:t>
+                        <a:t>Unique generated registration code (indexed).</a:t>
                       </a:r>
                     </a:p>
                   </a:txBody>
@@ -10225,7 +10345,7 @@
                         </a:defRPr>
                       </a:pPr>
                       <a:r>
-                        <a:t>Candidate email address (indexes speed up sign-in lookup).</a:t>
+                        <a:t>Unique applicant email (indexed to optimize lookup speed).</a:t>
                       </a:r>
                     </a:p>
                   </a:txBody>
@@ -10250,7 +10370,7 @@
                         </a:defRPr>
                       </a:pPr>
                       <a:r>
-                        <a:t>major</a:t>
+                        <a:t>dob</a:t>
                       </a:r>
                     </a:p>
                   </a:txBody>
@@ -10273,7 +10393,7 @@
                         </a:defRPr>
                       </a:pPr>
                       <a:r>
-                        <a:t>VARCHAR(100) NOT NULL</a:t>
+                        <a:t>DATE NOT NULL</a:t>
                       </a:r>
                     </a:p>
                   </a:txBody>
@@ -10296,7 +10416,7 @@
                         </a:defRPr>
                       </a:pPr>
                       <a:r>
-                        <a:t>Selected major (e.g. Computer Science, Data Science, etc.).</a:t>
+                        <a:t>Candidate date of birth (enforces age validation).</a:t>
                       </a:r>
                     </a:p>
                   </a:txBody>
@@ -10321,7 +10441,7 @@
                         </a:defRPr>
                       </a:pPr>
                       <a:r>
-                        <a:t>password_hash</a:t>
+                        <a:t>major</a:t>
                       </a:r>
                     </a:p>
                   </a:txBody>
@@ -10344,7 +10464,7 @@
                         </a:defRPr>
                       </a:pPr>
                       <a:r>
-                        <a:t>VARCHAR(255) NOT NULL</a:t>
+                        <a:t>VARCHAR(100) NOT NULL</a:t>
                       </a:r>
                     </a:p>
                   </a:txBody>
@@ -10367,7 +10487,7 @@
                         </a:defRPr>
                       </a:pPr>
                       <a:r>
-                        <a:t>Encrypted password string computed via Bcrypt algorithm.</a:t>
+                        <a:t>Selected major program (Computer Science, Data Science, etc.).</a:t>
                       </a:r>
                     </a:p>
                   </a:txBody>
@@ -10392,7 +10512,7 @@
                         </a:defRPr>
                       </a:pPr>
                       <a:r>
-                        <a:t>registration_date</a:t>
+                        <a:t>password_hash</a:t>
                       </a:r>
                     </a:p>
                   </a:txBody>
@@ -10415,7 +10535,7 @@
                         </a:defRPr>
                       </a:pPr>
                       <a:r>
-                        <a:t>DATETIME NOT NULL</a:t>
+                        <a:t>VARCHAR(255) NOT NULL</a:t>
                       </a:r>
                     </a:p>
                   </a:txBody>
@@ -10438,7 +10558,7 @@
                         </a:defRPr>
                       </a:pPr>
                       <a:r>
-                        <a:t>Candidate creation timestamp (Defaults to CURRENT_TIMESTAMP).</a:t>
+                        <a:t>Secure password string encrypted using Bcrypt (rounds: 12).</a:t>
                       </a:r>
                     </a:p>
                   </a:txBody>
@@ -10880,7 +11000,7 @@
                         </a:defRPr>
                       </a:pPr>
                       <a:r>
-                        <a:t>Unique login ID</a:t>
+                        <a:t>Unique login username</a:t>
                       </a:r>
                     </a:p>
                   </a:txBody>
@@ -10951,7 +11071,7 @@
                         </a:defRPr>
                       </a:pPr>
                       <a:r>
-                        <a:t>Unique contact</a:t>
+                        <a:t>Unique administrative contact</a:t>
                       </a:r>
                     </a:p>
                   </a:txBody>
@@ -11022,7 +11142,7 @@
                         </a:defRPr>
                       </a:pPr>
                       <a:r>
-                        <a:t>Bcrypt signature</a:t>
+                        <a:t>Secure Bcrypt password signature</a:t>
                       </a:r>
                     </a:p>
                   </a:txBody>
@@ -11067,7 +11187,7 @@
               </a:defRPr>
             </a:pPr>
             <a:r>
-              <a:t>System Relationships Overview</a:t>
+              <a:t>Dynamic Authorization Schema</a:t>
             </a:r>
           </a:p>
         </p:txBody>
@@ -11132,7 +11252,7 @@
                         </a:defRPr>
                       </a:pPr>
                       <a:r>
-                        <a:t>Security Level</a:t>
+                        <a:t>Security Policy</a:t>
                       </a:r>
                     </a:p>
                   </a:txBody>
@@ -11155,7 +11275,7 @@
                         </a:defRPr>
                       </a:pPr>
                       <a:r>
-                        <a:t>Description</a:t>
+                        <a:t>Session Validation Action</a:t>
                       </a:r>
                     </a:p>
                   </a:txBody>
@@ -11180,7 +11300,7 @@
                         </a:defRPr>
                       </a:pPr>
                       <a:r>
-                        <a:t>Student -&gt; Session</a:t>
+                        <a:t>Student session</a:t>
                       </a:r>
                     </a:p>
                   </a:txBody>
@@ -11203,7 +11323,7 @@
                         </a:defRPr>
                       </a:pPr>
                       <a:r>
-                        <a:t>Student Cookies</a:t>
+                        <a:t>HttpOnly Cookie</a:t>
                       </a:r>
                     </a:p>
                   </a:txBody>
@@ -11226,7 +11346,7 @@
                         </a:defRPr>
                       </a:pPr>
                       <a:r>
-                        <a:t>Isolated cookies protect student credentials.</a:t>
+                        <a:t>Saves regular integer ID in server session.</a:t>
                       </a:r>
                     </a:p>
                   </a:txBody>
@@ -11251,7 +11371,7 @@
                         </a:defRPr>
                       </a:pPr>
                       <a:r>
-                        <a:t>Admin -&gt; Session</a:t>
+                        <a:t>Admin session</a:t>
                       </a:r>
                     </a:p>
                   </a:txBody>
@@ -11274,7 +11394,7 @@
                         </a:defRPr>
                       </a:pPr>
                       <a:r>
-                        <a:t>Admin Cookie check</a:t>
+                        <a:t>HttpOnly Cookie</a:t>
                       </a:r>
                     </a:p>
                   </a:txBody>
@@ -11297,7 +11417,7 @@
                         </a:defRPr>
                       </a:pPr>
                       <a:r>
-                        <a:t>Enforces access blocks on endpoints.</a:t>
+                        <a:t>Prepends 'admin-' prefix to user loader key.</a:t>
                       </a:r>
                     </a:p>
                   </a:txBody>
@@ -11322,7 +11442,7 @@
                         </a:defRPr>
                       </a:pPr>
                       <a:r>
-                        <a:t>Audit -&gt; Operations</a:t>
+                        <a:t>Audit Logging</a:t>
                       </a:r>
                     </a:p>
                   </a:txBody>
@@ -11345,7 +11465,7 @@
                         </a:defRPr>
                       </a:pPr>
                       <a:r>
-                        <a:t>Backend log file</a:t>
+                        <a:t>JSON formatting</a:t>
                       </a:r>
                     </a:p>
                   </a:txBody>
@@ -11368,7 +11488,7 @@
                         </a:defRPr>
                       </a:pPr>
                       <a:r>
-                        <a:t>Records administrative changes.</a:t>
+                        <a:t>Triggers logs inside audit.py on changes.</a:t>
                       </a:r>
                     </a:p>
                   </a:txBody>
@@ -11393,7 +11513,7 @@
                         </a:defRPr>
                       </a:pPr>
                       <a:r>
-                        <a:t>JWT -&gt; API Stats</a:t>
+                        <a:t>REST Access</a:t>
                       </a:r>
                     </a:p>
                   </a:txBody>
@@ -11416,7 +11536,7 @@
                         </a:defRPr>
                       </a:pPr>
                       <a:r>
-                        <a:t>Crypto signature</a:t>
+                        <a:t>JWT validation</a:t>
                       </a:r>
                     </a:p>
                   </a:txBody>
@@ -11439,7 +11559,7 @@
                         </a:defRPr>
                       </a:pPr>
                       <a:r>
-                        <a:t>Secures analytics lookups.</a:t>
+                        <a:t>API routes verify cryptographic tokens.</a:t>
                       </a:r>
                     </a:p>
                   </a:txBody>
@@ -11488,7 +11608,7 @@
               </a:defRPr>
             </a:pPr>
             <a:r>
-              <a:t>💡 **Schema Integrity Rules:**</a:t>
+              <a:t>💡 **Verification &amp; Role Isolation:**</a:t>
             </a:r>
           </a:p>
           <a:p>
@@ -11501,11 +11621,11 @@
               </a:defRPr>
             </a:pPr>
             <a:r>
-              <a:t>• Unique constraints are evaluated by Flask validators before DB operations are attempted.</a:t>
+              <a:t>• Separation of Concerns: The system checks the Admins table first. If a match is found, session IDs are stored with an 'admin-' prefix, ensuring complete partition from Student accounts.</a:t>
             </a:r>
             <a:br/>
             <a:r>
-              <a:t>• Administrator credentials and regular student credentials are kept separated via dedicated Flask session identifiers, preventing privilege escalation.</a:t>
+              <a:t>• Constraints Enforcement: Database uniqueness constraints prevent duplicated student IDs or candidate emails.</a:t>
             </a:r>
           </a:p>
         </p:txBody>
@@ -11627,7 +11747,7 @@
               </a:defRPr>
             </a:pPr>
             <a:r>
-              <a:t>SQL CRUD Operations: Write Actions</a:t>
+              <a:t>SQL CRUD: Write Actions (Inserts/Updates)</a:t>
             </a:r>
           </a:p>
         </p:txBody>
@@ -11711,7 +11831,7 @@
               </a:defRPr>
             </a:pPr>
             <a:r>
-              <a:t>The registration pipeline validates inputs and runs SQL write commands (inserts/updates) through SQLAlchemy transactions.</a:t>
+              <a:t>Student Hub maps write operations dynamically using SQLAlchemy ORM to run secure, SQL-injection-resistant database queries.</a:t>
             </a:r>
           </a:p>
           <a:p>
@@ -11727,7 +11847,7 @@
               </a:defRPr>
             </a:pPr>
             <a:r>
-              <a:t>📥 Candidate Registration: Generates a unique index ID and writes full personal, address, and academic records.</a:t>
+              <a:t>📥 Candidate Registration INSERT: Runs transaction inserts containing validated personal, address, and graduation details.</a:t>
             </a:r>
           </a:p>
           <a:p>
@@ -11743,7 +11863,7 @@
               </a:defRPr>
             </a:pPr>
             <a:r>
-              <a:t>🔒 Encrypted Write: Computes secure password hashes using Blowfish-based Bcrypt and stores the signature.</a:t>
+              <a:t>🔒 Encrypted Passwords: Computes salt and bcrypt hashes, writing the 255-character string to the database.</a:t>
             </a:r>
           </a:p>
           <a:p>
@@ -11759,7 +11879,7 @@
               </a:defRPr>
             </a:pPr>
             <a:r>
-              <a:t>📝 Candidate Edits: Translates form changes into dynamic SQL update queries.</a:t>
+              <a:t>✏️ Profile updates: Runs UPDATE statements matching the candidate session ID to alter contact details.</a:t>
             </a:r>
           </a:p>
         </p:txBody>
@@ -11843,7 +11963,7 @@
               </a:defRPr>
             </a:pPr>
             <a:r>
-              <a:t>SQL WRITE STATEMENT SAMPLES</a:t>
+              <a:t>RAW SQL WRITE STATEMENTS</a:t>
             </a:r>
           </a:p>
           <a:p>
@@ -11859,7 +11979,7 @@
               </a:defRPr>
             </a:pPr>
             <a:r>
-              <a:t>-- Insert a new student record</a:t>
+              <a:t>-- Registering a student</a:t>
             </a:r>
             <a:br/>
             <a:r>
@@ -11892,7 +12012,7 @@
             <a:br/>
             <a:br/>
             <a:r>
-              <a:t>-- Update student record</a:t>
+              <a:t>-- Updating candidate profile details</a:t>
             </a:r>
             <a:br/>
             <a:r>
@@ -12030,7 +12150,7 @@
               </a:defRPr>
             </a:pPr>
             <a:r>
-              <a:t>SQL CRUD Operations: Read &amp; Analytics</a:t>
+              <a:t>SQL CRUD: Reads &amp; Aggregation Analytics</a:t>
             </a:r>
           </a:p>
         </p:txBody>
@@ -12114,7 +12234,7 @@
               </a:defRPr>
             </a:pPr>
             <a:r>
-              <a:t>Administrative pages run SQL queries to search records, filter results, and generate analytics.</a:t>
+              <a:t>The administrative dashboard processes dynamically filtered SELECT queries to support real-time searches and stats summaries.</a:t>
             </a:r>
           </a:p>
           <a:p>
@@ -12130,7 +12250,7 @@
               </a:defRPr>
             </a:pPr>
             <a:r>
-              <a:t>🔍 Roster Search Query: Matches search queries against candidate names, email formats, and unique IDs.</a:t>
+              <a:t>🔍 Roster Search &amp; Sorting: Uses multiple SQL `OR` conditions and dynamic column sorting variables.</a:t>
             </a:r>
           </a:p>
           <a:p>
@@ -12146,7 +12266,7 @@
               </a:defRPr>
             </a:pPr>
             <a:r>
-              <a:t>📊 Dynamic Aggregations: Computes enrollment totals and groups records by academic major.</a:t>
+              <a:t>📊 Dynamic Aggregations: Groups candidate registries by selected major to render charts.</a:t>
             </a:r>
           </a:p>
           <a:p>
@@ -12162,7 +12282,7 @@
               </a:defRPr>
             </a:pPr>
             <a:r>
-              <a:t>🔐 Token Credentials Verification: Validates account passwords and matches Bcrypt hashes during login.</a:t>
+              <a:t>🔐 Credentials validation: Matches username and loads password hashes to evaluate logins.</a:t>
             </a:r>
           </a:p>
         </p:txBody>
@@ -12246,7 +12366,7 @@
               </a:defRPr>
             </a:pPr>
             <a:r>
-              <a:t>SQL READ &amp; ANALYTICS SAMPLES</a:t>
+              <a:t>RAW SQL READ &amp; STATS STATEMENTS</a:t>
             </a:r>
           </a:p>
           <a:p>
@@ -12262,7 +12382,7 @@
               </a:defRPr>
             </a:pPr>
             <a:r>
-              <a:t>-- Administrative dynamic search &amp; sort</a:t>
+              <a:t>-- Search and Sort candidate table</a:t>
             </a:r>
             <a:br/>
             <a:r>
@@ -12287,11 +12407,11 @@
             <a:br/>
             <a:br/>
             <a:r>
-              <a:t>-- Major breakdown aggregation query</a:t>
+              <a:t>-- Aggregations for Chart.js dashboard</a:t>
             </a:r>
             <a:br/>
             <a:r>
-              <a:t>SELECT major, COUNT(*) AS enrollments </a:t>
+              <a:t>SELECT major, COUNT(*) AS count </a:t>
             </a:r>
             <a:br/>
             <a:r>

</xml_diff>